<commit_message>
Se agregan mejoras en el plan de pruebas. Se agrega documentación y se refactorizan pruebas del plan de pruebas de validgate.
</commit_message>
<xml_diff>
--- a/docs/validgate-context/resources/VALIDGATE.pptx
+++ b/docs/validgate-context/resources/VALIDGATE.pptx
@@ -188,7 +188,7 @@
 </file>
 
 <file path=ppt/diagrams/colors1.xml><?xml version="1.0" encoding="utf-8"?>
-<dgm:colorsDef xmlns:dgm="http://schemas.openxmlformats.org/drawingml/2006/diagram" xmlns:a="http://schemas.openxmlformats.org/drawingml/2006/main" uniqueId="urn:microsoft.com/office/officeart/2005/8/colors/accent1_2">
+<dgm:colorsDef xmlns:dgm="http://schemas.openxmlformats.org/drawingml/2006/diagram" xmlns:a="http://schemas.openxmlformats.org/drawingml/2006/main" uniqueId="urn:microsoft.com/office/officeart/2005/8/colors/accent1_2#1">
   <dgm:title val=""/>
   <dgm:desc val=""/>
   <dgm:catLst>
@@ -935,7 +935,7 @@
 </file>
 
 <file path=ppt/diagrams/colors2.xml><?xml version="1.0" encoding="utf-8"?>
-<dgm:colorsDef xmlns:dgm="http://schemas.openxmlformats.org/drawingml/2006/diagram" xmlns:a="http://schemas.openxmlformats.org/drawingml/2006/main" uniqueId="urn:microsoft.com/office/officeart/2005/8/colors/accent1_2">
+<dgm:colorsDef xmlns:dgm="http://schemas.openxmlformats.org/drawingml/2006/diagram" xmlns:a="http://schemas.openxmlformats.org/drawingml/2006/main" uniqueId="urn:microsoft.com/office/officeart/2005/8/colors/accent1_2#2">
   <dgm:title val=""/>
   <dgm:desc val=""/>
   <dgm:catLst>
@@ -1682,7 +1682,7 @@
 </file>
 
 <file path=ppt/diagrams/colors3.xml><?xml version="1.0" encoding="utf-8"?>
-<dgm:colorsDef xmlns:dgm="http://schemas.openxmlformats.org/drawingml/2006/diagram" xmlns:a="http://schemas.openxmlformats.org/drawingml/2006/main" uniqueId="urn:microsoft.com/office/officeart/2005/8/colors/accent1_2">
+<dgm:colorsDef xmlns:dgm="http://schemas.openxmlformats.org/drawingml/2006/diagram" xmlns:a="http://schemas.openxmlformats.org/drawingml/2006/main" uniqueId="urn:microsoft.com/office/officeart/2005/8/colors/accent1_2#3">
   <dgm:title val=""/>
   <dgm:desc val=""/>
   <dgm:catLst>
@@ -2432,7 +2432,7 @@
 <dgm:dataModel xmlns:dgm="http://schemas.openxmlformats.org/drawingml/2006/diagram" xmlns:a="http://schemas.openxmlformats.org/drawingml/2006/main">
   <dgm:ptLst>
     <dgm:pt modelId="{FCC8282E-3796-4FBA-B44E-BD5490DD2371}" type="doc">
-      <dgm:prSet loTypeId="urn:microsoft.com/office/officeart/2005/8/layout/process1" loCatId="process" qsTypeId="urn:microsoft.com/office/officeart/2005/8/quickstyle/simple1" qsCatId="simple" csTypeId="urn:microsoft.com/office/officeart/2005/8/colors/accent1_2" csCatId="accent1" phldr="1"/>
+      <dgm:prSet loTypeId="urn:microsoft.com/office/officeart/2005/8/layout/process1" loCatId="process" qsTypeId="urn:microsoft.com/office/officeart/2005/8/quickstyle/simple1#1" qsCatId="simple" csTypeId="urn:microsoft.com/office/officeart/2005/8/colors/accent1_2#1" csCatId="accent1" phldr="1"/>
       <dgm:spPr/>
       <dgm:t>
         <a:bodyPr/>
@@ -2767,7 +2767,7 @@
 <dgm:dataModel xmlns:dgm="http://schemas.openxmlformats.org/drawingml/2006/diagram" xmlns:a="http://schemas.openxmlformats.org/drawingml/2006/main">
   <dgm:ptLst>
     <dgm:pt modelId="{C720AB6A-8982-4669-84AD-4489995E7293}" type="doc">
-      <dgm:prSet loTypeId="urn:microsoft.com/office/officeart/2005/8/layout/orgChart1" loCatId="hierarchy" qsTypeId="urn:microsoft.com/office/officeart/2005/8/quickstyle/simple1" qsCatId="simple" csTypeId="urn:microsoft.com/office/officeart/2005/8/colors/accent1_2" csCatId="accent1" phldr="1"/>
+      <dgm:prSet loTypeId="urn:microsoft.com/office/officeart/2005/8/layout/orgChart1" loCatId="hierarchy" qsTypeId="urn:microsoft.com/office/officeart/2005/8/quickstyle/simple1#2" qsCatId="simple" csTypeId="urn:microsoft.com/office/officeart/2005/8/colors/accent1_2#2" csCatId="accent1" phldr="1"/>
       <dgm:spPr/>
       <dgm:t>
         <a:bodyPr/>
@@ -4986,7 +4986,7 @@
 <dgm:dataModel xmlns:dgm="http://schemas.openxmlformats.org/drawingml/2006/diagram" xmlns:a="http://schemas.openxmlformats.org/drawingml/2006/main">
   <dgm:ptLst>
     <dgm:pt modelId="{7DFD3C33-7085-4DFE-AEE3-8677AD69216A}" type="doc">
-      <dgm:prSet loTypeId="urn:microsoft.com/office/officeart/2009/3/layout/IncreasingArrowsProcess" loCatId="process" qsTypeId="urn:microsoft.com/office/officeart/2005/8/quickstyle/simple1" qsCatId="simple" csTypeId="urn:microsoft.com/office/officeart/2005/8/colors/accent1_2" csCatId="accent1" phldr="1"/>
+      <dgm:prSet loTypeId="urn:microsoft.com/office/officeart/2009/3/layout/IncreasingArrowsProcess" loCatId="process" qsTypeId="urn:microsoft.com/office/officeart/2005/8/quickstyle/simple1#3" qsCatId="simple" csTypeId="urn:microsoft.com/office/officeart/2005/8/colors/accent1_2#3" csCatId="accent1" phldr="1"/>
       <dgm:spPr/>
       <dgm:t>
         <a:bodyPr/>
@@ -13574,7 +13574,7 @@
 </file>
 
 <file path=ppt/diagrams/quickStyle1.xml><?xml version="1.0" encoding="utf-8"?>
-<dgm:styleDef xmlns:dgm="http://schemas.openxmlformats.org/drawingml/2006/diagram" xmlns:a="http://schemas.openxmlformats.org/drawingml/2006/main" uniqueId="urn:microsoft.com/office/officeart/2005/8/quickstyle/simple1">
+<dgm:styleDef xmlns:dgm="http://schemas.openxmlformats.org/drawingml/2006/diagram" xmlns:a="http://schemas.openxmlformats.org/drawingml/2006/main" uniqueId="urn:microsoft.com/office/officeart/2005/8/quickstyle/simple1#1">
   <dgm:title val=""/>
   <dgm:desc val=""/>
   <dgm:catLst>
@@ -14608,7 +14608,7 @@
 </file>
 
 <file path=ppt/diagrams/quickStyle2.xml><?xml version="1.0" encoding="utf-8"?>
-<dgm:styleDef xmlns:dgm="http://schemas.openxmlformats.org/drawingml/2006/diagram" xmlns:a="http://schemas.openxmlformats.org/drawingml/2006/main" uniqueId="urn:microsoft.com/office/officeart/2005/8/quickstyle/simple1">
+<dgm:styleDef xmlns:dgm="http://schemas.openxmlformats.org/drawingml/2006/diagram" xmlns:a="http://schemas.openxmlformats.org/drawingml/2006/main" uniqueId="urn:microsoft.com/office/officeart/2005/8/quickstyle/simple1#2">
   <dgm:title val=""/>
   <dgm:desc val=""/>
   <dgm:catLst>
@@ -15642,7 +15642,7 @@
 </file>
 
 <file path=ppt/diagrams/quickStyle3.xml><?xml version="1.0" encoding="utf-8"?>
-<dgm:styleDef xmlns:dgm="http://schemas.openxmlformats.org/drawingml/2006/diagram" xmlns:a="http://schemas.openxmlformats.org/drawingml/2006/main" uniqueId="urn:microsoft.com/office/officeart/2005/8/quickstyle/simple1">
+<dgm:styleDef xmlns:dgm="http://schemas.openxmlformats.org/drawingml/2006/diagram" xmlns:a="http://schemas.openxmlformats.org/drawingml/2006/main" uniqueId="urn:microsoft.com/office/officeart/2005/8/quickstyle/simple1#3">
   <dgm:title val=""/>
   <dgm:desc val=""/>
   <dgm:catLst>
@@ -16757,7 +16757,7 @@
           <a:p>
             <a:fld id="{89347D60-E39B-E041-B6CE-3FDC1A8BB989}" type="datetimeFigureOut">
               <a:rPr lang="es-ES_tradnl" smtClean="0"/>
-              <a:t>11/07/2026</a:t>
+              <a:t>22/08/2026</a:t>
             </a:fld>
             <a:endParaRPr lang="es-ES_tradnl" dirty="0"/>
           </a:p>
@@ -21906,7 +21906,7 @@
           <a:p>
             <a:fld id="{6FD36221-589F-2846-B89B-D09559D774BF}" type="datetimeFigureOut">
               <a:rPr lang="es-ES_tradnl" smtClean="0"/>
-              <a:t>11/07/2026</a:t>
+              <a:t>22/08/2026</a:t>
             </a:fld>
             <a:endParaRPr lang="es-ES_tradnl" dirty="0"/>
           </a:p>
@@ -22071,7 +22071,7 @@
           <a:p>
             <a:fld id="{6FD36221-589F-2846-B89B-D09559D774BF}" type="datetimeFigureOut">
               <a:rPr lang="es-ES_tradnl" smtClean="0"/>
-              <a:t>11/07/2026</a:t>
+              <a:t>22/08/2026</a:t>
             </a:fld>
             <a:endParaRPr lang="es-ES_tradnl" dirty="0"/>
           </a:p>
@@ -22246,7 +22246,7 @@
           <a:p>
             <a:fld id="{6FD36221-589F-2846-B89B-D09559D774BF}" type="datetimeFigureOut">
               <a:rPr lang="es-ES_tradnl" smtClean="0"/>
-              <a:t>11/07/2026</a:t>
+              <a:t>22/08/2026</a:t>
             </a:fld>
             <a:endParaRPr lang="es-ES_tradnl" dirty="0"/>
           </a:p>
@@ -22411,7 +22411,7 @@
           <a:p>
             <a:fld id="{6FD36221-589F-2846-B89B-D09559D774BF}" type="datetimeFigureOut">
               <a:rPr lang="es-ES_tradnl" smtClean="0"/>
-              <a:t>11/07/2026</a:t>
+              <a:t>22/08/2026</a:t>
             </a:fld>
             <a:endParaRPr lang="es-ES_tradnl" dirty="0"/>
           </a:p>
@@ -22650,7 +22650,7 @@
           <a:p>
             <a:fld id="{6FD36221-589F-2846-B89B-D09559D774BF}" type="datetimeFigureOut">
               <a:rPr lang="es-ES_tradnl" smtClean="0"/>
-              <a:t>11/07/2026</a:t>
+              <a:t>22/08/2026</a:t>
             </a:fld>
             <a:endParaRPr lang="es-ES_tradnl" dirty="0"/>
           </a:p>
@@ -22877,7 +22877,7 @@
           <a:p>
             <a:fld id="{6FD36221-589F-2846-B89B-D09559D774BF}" type="datetimeFigureOut">
               <a:rPr lang="es-ES_tradnl" smtClean="0"/>
-              <a:t>11/07/2026</a:t>
+              <a:t>22/08/2026</a:t>
             </a:fld>
             <a:endParaRPr lang="es-ES_tradnl" dirty="0"/>
           </a:p>
@@ -23239,7 +23239,7 @@
           <a:p>
             <a:fld id="{6FD36221-589F-2846-B89B-D09559D774BF}" type="datetimeFigureOut">
               <a:rPr lang="es-ES_tradnl" smtClean="0"/>
-              <a:t>11/07/2026</a:t>
+              <a:t>22/08/2026</a:t>
             </a:fld>
             <a:endParaRPr lang="es-ES_tradnl" dirty="0"/>
           </a:p>
@@ -23352,7 +23352,7 @@
           <a:p>
             <a:fld id="{6FD36221-589F-2846-B89B-D09559D774BF}" type="datetimeFigureOut">
               <a:rPr lang="es-ES_tradnl" smtClean="0"/>
-              <a:t>11/07/2026</a:t>
+              <a:t>22/08/2026</a:t>
             </a:fld>
             <a:endParaRPr lang="es-ES_tradnl" dirty="0"/>
           </a:p>
@@ -23442,7 +23442,7 @@
           <a:p>
             <a:fld id="{6FD36221-589F-2846-B89B-D09559D774BF}" type="datetimeFigureOut">
               <a:rPr lang="es-ES_tradnl" smtClean="0"/>
-              <a:t>11/07/2026</a:t>
+              <a:t>22/08/2026</a:t>
             </a:fld>
             <a:endParaRPr lang="es-ES_tradnl" dirty="0"/>
           </a:p>
@@ -23714,7 +23714,7 @@
           <a:p>
             <a:fld id="{6FD36221-589F-2846-B89B-D09559D774BF}" type="datetimeFigureOut">
               <a:rPr lang="es-ES_tradnl" smtClean="0"/>
-              <a:t>11/07/2026</a:t>
+              <a:t>22/08/2026</a:t>
             </a:fld>
             <a:endParaRPr lang="es-ES_tradnl" dirty="0"/>
           </a:p>
@@ -23966,7 +23966,7 @@
           <a:p>
             <a:fld id="{6FD36221-589F-2846-B89B-D09559D774BF}" type="datetimeFigureOut">
               <a:rPr lang="es-ES_tradnl" smtClean="0"/>
-              <a:t>11/07/2026</a:t>
+              <a:t>22/08/2026</a:t>
             </a:fld>
             <a:endParaRPr lang="es-ES_tradnl" dirty="0"/>
           </a:p>
@@ -24174,7 +24174,7 @@
           <a:p>
             <a:fld id="{6FD36221-589F-2846-B89B-D09559D774BF}" type="datetimeFigureOut">
               <a:rPr lang="es-ES_tradnl" smtClean="0"/>
-              <a:t>11/07/2026</a:t>
+              <a:t>22/08/2026</a:t>
             </a:fld>
             <a:endParaRPr lang="es-ES_tradnl" dirty="0"/>
           </a:p>
@@ -31966,287 +31966,910 @@
       </p:sp>
       <p:graphicFrame>
         <p:nvGraphicFramePr>
-          <p:cNvPr id="4" name="Objeto 3">
+          <p:cNvPr id="4" name="Tabla 3">
             <a:extLst>
               <a:ext uri="{FF2B5EF4-FFF2-40B4-BE49-F238E27FC236}">
-                <a16:creationId xmlns:a16="http://schemas.microsoft.com/office/drawing/2014/main" id="{4A4DA2AD-593B-37A2-12E3-5C5E7A9E9220}"/>
+                <a16:creationId xmlns:a16="http://schemas.microsoft.com/office/drawing/2014/main" id="{E9D0E25A-BF28-0B9D-DBAD-35AAF8A4BC4C}"/>
               </a:ext>
             </a:extLst>
           </p:cNvPr>
           <p:cNvGraphicFramePr>
-            <a:graphicFrameLocks noChangeAspect="1"/>
+            <a:graphicFrameLocks noGrp="1"/>
           </p:cNvGraphicFramePr>
           <p:nvPr>
             <p:extLst>
               <p:ext uri="{D42A27DB-BD31-4B8C-83A1-F6EECF244321}">
-                <p14:modId xmlns:p14="http://schemas.microsoft.com/office/powerpoint/2010/main" val="3803529368"/>
+                <p14:modId xmlns:p14="http://schemas.microsoft.com/office/powerpoint/2010/main" val="962862597"/>
               </p:ext>
             </p:extLst>
           </p:nvPr>
         </p:nvGraphicFramePr>
         <p:xfrm>
-          <a:off x="1050471" y="1212702"/>
-          <a:ext cx="7984807" cy="2760584"/>
+          <a:off x="825500" y="1168400"/>
+          <a:ext cx="7493000" cy="2730500"/>
         </p:xfrm>
         <a:graphic>
-          <a:graphicData uri="http://schemas.openxmlformats.org/presentationml/2006/ole">
-            <mc:AlternateContent xmlns:mc="http://schemas.openxmlformats.org/markup-compatibility/2006">
-              <mc:Choice xmlns:v="urn:schemas-microsoft-com:vml" Requires="v">
-                <p:oleObj name="Document" r:id="rId5" imgW="5944043" imgH="2016072" progId="Word.Document.12">
-                  <p:embed/>
-                </p:oleObj>
-              </mc:Choice>
-              <mc:Fallback>
-                <p:oleObj name="Document" r:id="rId5" imgW="5944043" imgH="2016072" progId="Word.Document.12">
-                  <p:embed/>
-                  <p:pic>
-                    <p:nvPicPr>
-                      <p:cNvPr id="4" name="Objeto 3">
-                        <a:extLst>
-                          <a:ext uri="{FF2B5EF4-FFF2-40B4-BE49-F238E27FC236}">
-                            <a16:creationId xmlns:a16="http://schemas.microsoft.com/office/drawing/2014/main" id="{4A4DA2AD-593B-37A2-12E3-5C5E7A9E9220}"/>
-                          </a:ext>
-                        </a:extLst>
-                      </p:cNvPr>
-                      <p:cNvPicPr/>
-                      <p:nvPr/>
-                    </p:nvPicPr>
-                    <p:blipFill>
-                      <a:blip r:embed="rId6"/>
-                      <a:stretch>
-                        <a:fillRect/>
-                      </a:stretch>
-                    </p:blipFill>
-                    <p:spPr>
-                      <a:xfrm>
-                        <a:off x="1050471" y="1212702"/>
-                        <a:ext cx="7984807" cy="2760584"/>
-                      </a:xfrm>
-                      <a:prstGeom prst="rect">
-                        <a:avLst/>
-                      </a:prstGeom>
-                    </p:spPr>
-                  </p:pic>
-                </p:oleObj>
-              </mc:Fallback>
-            </mc:AlternateContent>
+          <a:graphicData uri="http://schemas.openxmlformats.org/drawingml/2006/table">
+            <a:tbl>
+              <a:tblPr firstRow="1" bandRow="1">
+                <a:tableStyleId>{5C22544A-7EE6-4342-B048-85BDC9FD1C3A}</a:tableStyleId>
+              </a:tblPr>
+              <a:tblGrid>
+                <a:gridCol w="2032000">
+                  <a:extLst>
+                    <a:ext uri="{9D8B030D-6E8A-4147-A177-3AD203B41FA5}">
+                      <a16:colId xmlns:a16="http://schemas.microsoft.com/office/drawing/2014/main" val="3092234367"/>
+                    </a:ext>
+                  </a:extLst>
+                </a:gridCol>
+                <a:gridCol w="2349500">
+                  <a:extLst>
+                    <a:ext uri="{9D8B030D-6E8A-4147-A177-3AD203B41FA5}">
+                      <a16:colId xmlns:a16="http://schemas.microsoft.com/office/drawing/2014/main" val="516225204"/>
+                    </a:ext>
+                  </a:extLst>
+                </a:gridCol>
+                <a:gridCol w="3111500">
+                  <a:extLst>
+                    <a:ext uri="{9D8B030D-6E8A-4147-A177-3AD203B41FA5}">
+                      <a16:colId xmlns:a16="http://schemas.microsoft.com/office/drawing/2014/main" val="2635861832"/>
+                    </a:ext>
+                  </a:extLst>
+                </a:gridCol>
+              </a:tblGrid>
+              <a:tr h="303389">
+                <a:tc>
+                  <a:txBody>
+                    <a:bodyPr/>
+                    <a:lstStyle/>
+                    <a:p>
+                      <a:pPr algn="ctr"/>
+                      <a:r>
+                        <a:rPr lang="es-CL" sz="1400" b="1">
+                          <a:solidFill>
+                            <a:srgbClr val="FFFFFF"/>
+                          </a:solidFill>
+                          <a:latin typeface="Arial" panose="020B0604020202020204" pitchFamily="34" charset="0"/>
+                        </a:rPr>
+                        <a:t>Componente</a:t>
+                      </a:r>
+                    </a:p>
+                  </a:txBody>
+                  <a:tcPr marL="50800" marR="50800" anchor="ctr">
+                    <a:solidFill>
+                      <a:srgbClr val="3B85D5"/>
+                    </a:solidFill>
+                  </a:tcPr>
+                </a:tc>
+                <a:tc>
+                  <a:txBody>
+                    <a:bodyPr/>
+                    <a:lstStyle/>
+                    <a:p>
+                      <a:pPr algn="ctr"/>
+                      <a:r>
+                        <a:rPr lang="es-CL" sz="1400" b="1">
+                          <a:solidFill>
+                            <a:srgbClr val="FFFFFF"/>
+                          </a:solidFill>
+                          <a:latin typeface="Arial" panose="020B0604020202020204" pitchFamily="34" charset="0"/>
+                        </a:rPr>
+                        <a:t>Tecnología</a:t>
+                      </a:r>
+                    </a:p>
+                  </a:txBody>
+                  <a:tcPr marL="50800" marR="50800" anchor="ctr">
+                    <a:solidFill>
+                      <a:srgbClr val="3B85D5"/>
+                    </a:solidFill>
+                  </a:tcPr>
+                </a:tc>
+                <a:tc>
+                  <a:txBody>
+                    <a:bodyPr/>
+                    <a:lstStyle/>
+                    <a:p>
+                      <a:pPr algn="ctr"/>
+                      <a:r>
+                        <a:rPr lang="es-CL" sz="1400" b="1">
+                          <a:solidFill>
+                            <a:srgbClr val="FFFFFF"/>
+                          </a:solidFill>
+                          <a:latin typeface="Arial" panose="020B0604020202020204" pitchFamily="34" charset="0"/>
+                        </a:rPr>
+                        <a:t>Propósito</a:t>
+                      </a:r>
+                    </a:p>
+                  </a:txBody>
+                  <a:tcPr marL="50800" marR="50800" anchor="ctr">
+                    <a:solidFill>
+                      <a:srgbClr val="3B85D5"/>
+                    </a:solidFill>
+                  </a:tcPr>
+                </a:tc>
+                <a:extLst>
+                  <a:ext uri="{0D108BD9-81ED-4DB2-BD59-A6C34878D82A}">
+                    <a16:rowId xmlns:a16="http://schemas.microsoft.com/office/drawing/2014/main" val="3573938395"/>
+                  </a:ext>
+                </a:extLst>
+              </a:tr>
+              <a:tr h="303389">
+                <a:tc>
+                  <a:txBody>
+                    <a:bodyPr/>
+                    <a:lstStyle/>
+                    <a:p>
+                      <a:pPr algn="ctr"/>
+                      <a:r>
+                        <a:rPr lang="es-CL" sz="1100">
+                          <a:latin typeface="Arial" panose="020B0604020202020204" pitchFamily="34" charset="0"/>
+                        </a:rPr>
+                        <a:t>Frontend</a:t>
+                      </a:r>
+                    </a:p>
+                  </a:txBody>
+                  <a:tcPr marL="50800" marR="50800" anchor="ctr">
+                    <a:solidFill>
+                      <a:srgbClr val="F7F7F7"/>
+                    </a:solidFill>
+                  </a:tcPr>
+                </a:tc>
+                <a:tc>
+                  <a:txBody>
+                    <a:bodyPr/>
+                    <a:lstStyle/>
+                    <a:p>
+                      <a:pPr algn="ctr"/>
+                      <a:r>
+                        <a:rPr lang="es-CL" sz="1100">
+                          <a:latin typeface="Arial" panose="020B0604020202020204" pitchFamily="34" charset="0"/>
+                        </a:rPr>
+                        <a:t>Next.js + React</a:t>
+                      </a:r>
+                    </a:p>
+                  </a:txBody>
+                  <a:tcPr marL="50800" marR="50800" anchor="ctr">
+                    <a:solidFill>
+                      <a:srgbClr val="F7F7F7"/>
+                    </a:solidFill>
+                  </a:tcPr>
+                </a:tc>
+                <a:tc>
+                  <a:txBody>
+                    <a:bodyPr/>
+                    <a:lstStyle/>
+                    <a:p>
+                      <a:pPr algn="ctr"/>
+                      <a:r>
+                        <a:rPr lang="es-CL" sz="1100">
+                          <a:latin typeface="Arial" panose="020B0604020202020204" pitchFamily="34" charset="0"/>
+                        </a:rPr>
+                        <a:t>Interfaz web del sistema</a:t>
+                      </a:r>
+                    </a:p>
+                  </a:txBody>
+                  <a:tcPr marL="50800" marR="50800" anchor="ctr">
+                    <a:solidFill>
+                      <a:srgbClr val="F7F7F7"/>
+                    </a:solidFill>
+                  </a:tcPr>
+                </a:tc>
+                <a:extLst>
+                  <a:ext uri="{0D108BD9-81ED-4DB2-BD59-A6C34878D82A}">
+                    <a16:rowId xmlns:a16="http://schemas.microsoft.com/office/drawing/2014/main" val="2480560004"/>
+                  </a:ext>
+                </a:extLst>
+              </a:tr>
+              <a:tr h="303389">
+                <a:tc>
+                  <a:txBody>
+                    <a:bodyPr/>
+                    <a:lstStyle/>
+                    <a:p>
+                      <a:pPr algn="ctr"/>
+                      <a:r>
+                        <a:rPr lang="es-CL" sz="1100">
+                          <a:latin typeface="Arial" panose="020B0604020202020204" pitchFamily="34" charset="0"/>
+                        </a:rPr>
+                        <a:t>Backend</a:t>
+                      </a:r>
+                    </a:p>
+                  </a:txBody>
+                  <a:tcPr marL="50800" marR="50800" anchor="ctr">
+                    <a:solidFill>
+                      <a:srgbClr val="FFFFFF"/>
+                    </a:solidFill>
+                  </a:tcPr>
+                </a:tc>
+                <a:tc>
+                  <a:txBody>
+                    <a:bodyPr/>
+                    <a:lstStyle/>
+                    <a:p>
+                      <a:pPr algn="ctr"/>
+                      <a:r>
+                        <a:rPr lang="es-CL" sz="1100">
+                          <a:latin typeface="Arial" panose="020B0604020202020204" pitchFamily="34" charset="0"/>
+                        </a:rPr>
+                        <a:t>Server Actions</a:t>
+                      </a:r>
+                    </a:p>
+                  </a:txBody>
+                  <a:tcPr marL="50800" marR="50800" anchor="ctr">
+                    <a:solidFill>
+                      <a:srgbClr val="FFFFFF"/>
+                    </a:solidFill>
+                  </a:tcPr>
+                </a:tc>
+                <a:tc>
+                  <a:txBody>
+                    <a:bodyPr/>
+                    <a:lstStyle/>
+                    <a:p>
+                      <a:pPr algn="ctr"/>
+                      <a:r>
+                        <a:rPr lang="es-CL" sz="1100">
+                          <a:latin typeface="Arial" panose="020B0604020202020204" pitchFamily="34" charset="0"/>
+                        </a:rPr>
+                        <a:t>Lógica de aplicación</a:t>
+                      </a:r>
+                    </a:p>
+                  </a:txBody>
+                  <a:tcPr marL="50800" marR="50800" anchor="ctr">
+                    <a:solidFill>
+                      <a:srgbClr val="FFFFFF"/>
+                    </a:solidFill>
+                  </a:tcPr>
+                </a:tc>
+                <a:extLst>
+                  <a:ext uri="{0D108BD9-81ED-4DB2-BD59-A6C34878D82A}">
+                    <a16:rowId xmlns:a16="http://schemas.microsoft.com/office/drawing/2014/main" val="2431216101"/>
+                  </a:ext>
+                </a:extLst>
+              </a:tr>
+              <a:tr h="303389">
+                <a:tc>
+                  <a:txBody>
+                    <a:bodyPr/>
+                    <a:lstStyle/>
+                    <a:p>
+                      <a:pPr algn="ctr"/>
+                      <a:r>
+                        <a:rPr lang="es-CL" sz="1100">
+                          <a:latin typeface="Arial" panose="020B0604020202020204" pitchFamily="34" charset="0"/>
+                        </a:rPr>
+                        <a:t>Estilos</a:t>
+                      </a:r>
+                    </a:p>
+                  </a:txBody>
+                  <a:tcPr marL="50800" marR="50800" anchor="ctr">
+                    <a:solidFill>
+                      <a:srgbClr val="F7F7F7"/>
+                    </a:solidFill>
+                  </a:tcPr>
+                </a:tc>
+                <a:tc>
+                  <a:txBody>
+                    <a:bodyPr/>
+                    <a:lstStyle/>
+                    <a:p>
+                      <a:pPr algn="ctr"/>
+                      <a:r>
+                        <a:rPr lang="es-CL" sz="1100">
+                          <a:latin typeface="Arial" panose="020B0604020202020204" pitchFamily="34" charset="0"/>
+                        </a:rPr>
+                        <a:t>Tailwind CSS</a:t>
+                      </a:r>
+                    </a:p>
+                  </a:txBody>
+                  <a:tcPr marL="50800" marR="50800" anchor="ctr">
+                    <a:solidFill>
+                      <a:srgbClr val="F7F7F7"/>
+                    </a:solidFill>
+                  </a:tcPr>
+                </a:tc>
+                <a:tc>
+                  <a:txBody>
+                    <a:bodyPr/>
+                    <a:lstStyle/>
+                    <a:p>
+                      <a:pPr algn="ctr"/>
+                      <a:r>
+                        <a:rPr lang="es-CL" sz="1100">
+                          <a:latin typeface="Arial" panose="020B0604020202020204" pitchFamily="34" charset="0"/>
+                        </a:rPr>
+                        <a:t>Diseño responsivo</a:t>
+                      </a:r>
+                    </a:p>
+                  </a:txBody>
+                  <a:tcPr marL="50800" marR="50800" anchor="ctr">
+                    <a:solidFill>
+                      <a:srgbClr val="F7F7F7"/>
+                    </a:solidFill>
+                  </a:tcPr>
+                </a:tc>
+                <a:extLst>
+                  <a:ext uri="{0D108BD9-81ED-4DB2-BD59-A6C34878D82A}">
+                    <a16:rowId xmlns:a16="http://schemas.microsoft.com/office/drawing/2014/main" val="1497023984"/>
+                  </a:ext>
+                </a:extLst>
+              </a:tr>
+              <a:tr h="303389">
+                <a:tc>
+                  <a:txBody>
+                    <a:bodyPr/>
+                    <a:lstStyle/>
+                    <a:p>
+                      <a:pPr algn="ctr"/>
+                      <a:r>
+                        <a:rPr lang="es-CL" sz="1100">
+                          <a:latin typeface="Arial" panose="020B0604020202020204" pitchFamily="34" charset="0"/>
+                        </a:rPr>
+                        <a:t>Servicios cloud</a:t>
+                      </a:r>
+                    </a:p>
+                  </a:txBody>
+                  <a:tcPr marL="50800" marR="50800" anchor="ctr">
+                    <a:solidFill>
+                      <a:srgbClr val="FFFFFF"/>
+                    </a:solidFill>
+                  </a:tcPr>
+                </a:tc>
+                <a:tc>
+                  <a:txBody>
+                    <a:bodyPr/>
+                    <a:lstStyle/>
+                    <a:p>
+                      <a:pPr algn="ctr"/>
+                      <a:r>
+                        <a:rPr lang="es-CL" sz="1100">
+                          <a:latin typeface="Arial" panose="020B0604020202020204" pitchFamily="34" charset="0"/>
+                        </a:rPr>
+                        <a:t>Supabase</a:t>
+                      </a:r>
+                    </a:p>
+                  </a:txBody>
+                  <a:tcPr marL="50800" marR="50800" anchor="ctr">
+                    <a:solidFill>
+                      <a:srgbClr val="FFFFFF"/>
+                    </a:solidFill>
+                  </a:tcPr>
+                </a:tc>
+                <a:tc>
+                  <a:txBody>
+                    <a:bodyPr/>
+                    <a:lstStyle/>
+                    <a:p>
+                      <a:pPr algn="ctr"/>
+                      <a:r>
+                        <a:rPr lang="es-CL" sz="1100">
+                          <a:latin typeface="Arial" panose="020B0604020202020204" pitchFamily="34" charset="0"/>
+                        </a:rPr>
+                        <a:t>Auth, API y RPC</a:t>
+                      </a:r>
+                    </a:p>
+                  </a:txBody>
+                  <a:tcPr marL="50800" marR="50800" anchor="ctr">
+                    <a:solidFill>
+                      <a:srgbClr val="FFFFFF"/>
+                    </a:solidFill>
+                  </a:tcPr>
+                </a:tc>
+                <a:extLst>
+                  <a:ext uri="{0D108BD9-81ED-4DB2-BD59-A6C34878D82A}">
+                    <a16:rowId xmlns:a16="http://schemas.microsoft.com/office/drawing/2014/main" val="1200018910"/>
+                  </a:ext>
+                </a:extLst>
+              </a:tr>
+              <a:tr h="303389">
+                <a:tc>
+                  <a:txBody>
+                    <a:bodyPr/>
+                    <a:lstStyle/>
+                    <a:p>
+                      <a:pPr algn="ctr"/>
+                      <a:r>
+                        <a:rPr lang="es-CL" sz="1100">
+                          <a:latin typeface="Arial" panose="020B0604020202020204" pitchFamily="34" charset="0"/>
+                        </a:rPr>
+                        <a:t>Persistencia</a:t>
+                      </a:r>
+                    </a:p>
+                  </a:txBody>
+                  <a:tcPr marL="50800" marR="50800" anchor="ctr">
+                    <a:solidFill>
+                      <a:srgbClr val="F7F7F7"/>
+                    </a:solidFill>
+                  </a:tcPr>
+                </a:tc>
+                <a:tc>
+                  <a:txBody>
+                    <a:bodyPr/>
+                    <a:lstStyle/>
+                    <a:p>
+                      <a:pPr algn="ctr"/>
+                      <a:r>
+                        <a:rPr lang="es-CL" sz="1100">
+                          <a:latin typeface="Arial" panose="020B0604020202020204" pitchFamily="34" charset="0"/>
+                        </a:rPr>
+                        <a:t>PostgreSQL + RLS</a:t>
+                      </a:r>
+                    </a:p>
+                  </a:txBody>
+                  <a:tcPr marL="50800" marR="50800" anchor="ctr">
+                    <a:solidFill>
+                      <a:srgbClr val="F7F7F7"/>
+                    </a:solidFill>
+                  </a:tcPr>
+                </a:tc>
+                <a:tc>
+                  <a:txBody>
+                    <a:bodyPr/>
+                    <a:lstStyle/>
+                    <a:p>
+                      <a:pPr algn="ctr"/>
+                      <a:r>
+                        <a:rPr lang="es-ES" sz="1100">
+                          <a:latin typeface="Arial" panose="020B0604020202020204" pitchFamily="34" charset="0"/>
+                        </a:rPr>
+                        <a:t>Datos y control por fila</a:t>
+                      </a:r>
+                      <a:endParaRPr lang="es-CL" sz="1100">
+                        <a:latin typeface="Arial" panose="020B0604020202020204" pitchFamily="34" charset="0"/>
+                      </a:endParaRPr>
+                    </a:p>
+                  </a:txBody>
+                  <a:tcPr marL="50800" marR="50800" anchor="ctr">
+                    <a:solidFill>
+                      <a:srgbClr val="F7F7F7"/>
+                    </a:solidFill>
+                  </a:tcPr>
+                </a:tc>
+                <a:extLst>
+                  <a:ext uri="{0D108BD9-81ED-4DB2-BD59-A6C34878D82A}">
+                    <a16:rowId xmlns:a16="http://schemas.microsoft.com/office/drawing/2014/main" val="806167999"/>
+                  </a:ext>
+                </a:extLst>
+              </a:tr>
+              <a:tr h="303389">
+                <a:tc>
+                  <a:txBody>
+                    <a:bodyPr/>
+                    <a:lstStyle/>
+                    <a:p>
+                      <a:pPr algn="ctr"/>
+                      <a:r>
+                        <a:rPr lang="es-CL" sz="1100">
+                          <a:latin typeface="Arial" panose="020B0604020202020204" pitchFamily="34" charset="0"/>
+                        </a:rPr>
+                        <a:t>Validación académica</a:t>
+                      </a:r>
+                    </a:p>
+                  </a:txBody>
+                  <a:tcPr marL="50800" marR="50800" anchor="ctr">
+                    <a:solidFill>
+                      <a:srgbClr val="FFFFFF"/>
+                    </a:solidFill>
+                  </a:tcPr>
+                </a:tc>
+                <a:tc>
+                  <a:txBody>
+                    <a:bodyPr/>
+                    <a:lstStyle/>
+                    <a:p>
+                      <a:pPr algn="ctr"/>
+                      <a:r>
+                        <a:rPr lang="es-CL" sz="1100">
+                          <a:latin typeface="Arial" panose="020B0604020202020204" pitchFamily="34" charset="0"/>
+                        </a:rPr>
+                        <a:t>PC local + Node.js</a:t>
+                      </a:r>
+                    </a:p>
+                  </a:txBody>
+                  <a:tcPr marL="50800" marR="50800" anchor="ctr">
+                    <a:solidFill>
+                      <a:srgbClr val="FFFFFF"/>
+                    </a:solidFill>
+                  </a:tcPr>
+                </a:tc>
+                <a:tc>
+                  <a:txBody>
+                    <a:bodyPr/>
+                    <a:lstStyle/>
+                    <a:p>
+                      <a:pPr algn="ctr"/>
+                      <a:r>
+                        <a:rPr lang="es-CL" sz="1100">
+                          <a:latin typeface="Arial" panose="020B0604020202020204" pitchFamily="34" charset="0"/>
+                        </a:rPr>
+                        <a:t>Build de producción local</a:t>
+                      </a:r>
+                    </a:p>
+                  </a:txBody>
+                  <a:tcPr marL="50800" marR="50800" anchor="ctr">
+                    <a:solidFill>
+                      <a:srgbClr val="FFFFFF"/>
+                    </a:solidFill>
+                  </a:tcPr>
+                </a:tc>
+                <a:extLst>
+                  <a:ext uri="{0D108BD9-81ED-4DB2-BD59-A6C34878D82A}">
+                    <a16:rowId xmlns:a16="http://schemas.microsoft.com/office/drawing/2014/main" val="2442279686"/>
+                  </a:ext>
+                </a:extLst>
+              </a:tr>
+              <a:tr h="303389">
+                <a:tc>
+                  <a:txBody>
+                    <a:bodyPr/>
+                    <a:lstStyle/>
+                    <a:p>
+                      <a:pPr algn="ctr"/>
+                      <a:r>
+                        <a:rPr lang="es-CL" sz="1100">
+                          <a:latin typeface="Arial" panose="020B0604020202020204" pitchFamily="34" charset="0"/>
+                        </a:rPr>
+                        <a:t>Pruebas</a:t>
+                      </a:r>
+                    </a:p>
+                  </a:txBody>
+                  <a:tcPr marL="50800" marR="50800" anchor="ctr">
+                    <a:solidFill>
+                      <a:srgbClr val="F7F7F7"/>
+                    </a:solidFill>
+                  </a:tcPr>
+                </a:tc>
+                <a:tc>
+                  <a:txBody>
+                    <a:bodyPr/>
+                    <a:lstStyle/>
+                    <a:p>
+                      <a:pPr algn="ctr"/>
+                      <a:r>
+                        <a:rPr lang="es-CL" sz="1100">
+                          <a:latin typeface="Arial" panose="020B0604020202020204" pitchFamily="34" charset="0"/>
+                        </a:rPr>
+                        <a:t>Playwright</a:t>
+                      </a:r>
+                    </a:p>
+                  </a:txBody>
+                  <a:tcPr marL="50800" marR="50800" anchor="ctr">
+                    <a:solidFill>
+                      <a:srgbClr val="F7F7F7"/>
+                    </a:solidFill>
+                  </a:tcPr>
+                </a:tc>
+                <a:tc>
+                  <a:txBody>
+                    <a:bodyPr/>
+                    <a:lstStyle/>
+                    <a:p>
+                      <a:pPr algn="ctr"/>
+                      <a:r>
+                        <a:rPr lang="es-CL" sz="1100">
+                          <a:latin typeface="Arial" panose="020B0604020202020204" pitchFamily="34" charset="0"/>
+                        </a:rPr>
+                        <a:t>Smoke y evidencia E2E</a:t>
+                      </a:r>
+                    </a:p>
+                  </a:txBody>
+                  <a:tcPr marL="50800" marR="50800" anchor="ctr">
+                    <a:solidFill>
+                      <a:srgbClr val="F7F7F7"/>
+                    </a:solidFill>
+                  </a:tcPr>
+                </a:tc>
+                <a:extLst>
+                  <a:ext uri="{0D108BD9-81ED-4DB2-BD59-A6C34878D82A}">
+                    <a16:rowId xmlns:a16="http://schemas.microsoft.com/office/drawing/2014/main" val="2821908853"/>
+                  </a:ext>
+                </a:extLst>
+              </a:tr>
+              <a:tr h="303389">
+                <a:tc>
+                  <a:txBody>
+                    <a:bodyPr/>
+                    <a:lstStyle/>
+                    <a:p>
+                      <a:pPr algn="ctr"/>
+                      <a:r>
+                        <a:rPr lang="es-CL" sz="1100">
+                          <a:latin typeface="Arial" panose="020B0604020202020204" pitchFamily="34" charset="0"/>
+                        </a:rPr>
+                        <a:t>Versiones</a:t>
+                      </a:r>
+                    </a:p>
+                  </a:txBody>
+                  <a:tcPr marL="50800" marR="50800" anchor="ctr">
+                    <a:solidFill>
+                      <a:srgbClr val="FFFFFF"/>
+                    </a:solidFill>
+                  </a:tcPr>
+                </a:tc>
+                <a:tc>
+                  <a:txBody>
+                    <a:bodyPr/>
+                    <a:lstStyle/>
+                    <a:p>
+                      <a:pPr algn="ctr"/>
+                      <a:r>
+                        <a:rPr lang="es-CL" sz="1100">
+                          <a:latin typeface="Arial" panose="020B0604020202020204" pitchFamily="34" charset="0"/>
+                        </a:rPr>
+                        <a:t>GitHub</a:t>
+                      </a:r>
+                    </a:p>
+                  </a:txBody>
+                  <a:tcPr marL="50800" marR="50800" anchor="ctr">
+                    <a:solidFill>
+                      <a:srgbClr val="FFFFFF"/>
+                    </a:solidFill>
+                  </a:tcPr>
+                </a:tc>
+                <a:tc>
+                  <a:txBody>
+                    <a:bodyPr/>
+                    <a:lstStyle/>
+                    <a:p>
+                      <a:pPr algn="ctr"/>
+                      <a:r>
+                        <a:rPr lang="es-CL" sz="1100">
+                          <a:latin typeface="Arial" panose="020B0604020202020204" pitchFamily="34" charset="0"/>
+                        </a:rPr>
+                        <a:t>Trazabilidad del código</a:t>
+                      </a:r>
+                    </a:p>
+                  </a:txBody>
+                  <a:tcPr marL="50800" marR="50800" anchor="ctr">
+                    <a:solidFill>
+                      <a:srgbClr val="FFFFFF"/>
+                    </a:solidFill>
+                  </a:tcPr>
+                </a:tc>
+                <a:extLst>
+                  <a:ext uri="{0D108BD9-81ED-4DB2-BD59-A6C34878D82A}">
+                    <a16:rowId xmlns:a16="http://schemas.microsoft.com/office/drawing/2014/main" val="2059532687"/>
+                  </a:ext>
+                </a:extLst>
+              </a:tr>
+            </a:tbl>
           </a:graphicData>
         </a:graphic>
       </p:graphicFrame>
-      <p:pic>
-        <p:nvPicPr>
-          <p:cNvPr id="1026" name="Picture 2" descr="Vercel icon - Free Download PNG &amp; SVG | Streamline">
+      <p:sp>
+        <p:nvSpPr>
+          <p:cNvPr id="8" name="Rectángulo: esquinas redondeadas 7">
             <a:extLst>
               <a:ext uri="{FF2B5EF4-FFF2-40B4-BE49-F238E27FC236}">
-                <a16:creationId xmlns:a16="http://schemas.microsoft.com/office/drawing/2014/main" id="{5B2208F6-C4A2-C3F4-A92B-1D4D6381C9EC}"/>
+                <a16:creationId xmlns:a16="http://schemas.microsoft.com/office/drawing/2014/main" id="{386198BA-5CF2-4737-D5D1-7C52B2CA3582}"/>
               </a:ext>
             </a:extLst>
           </p:cNvPr>
-          <p:cNvPicPr>
-            <a:picLocks noChangeAspect="1" noChangeArrowheads="1"/>
-          </p:cNvPicPr>
+          <p:cNvSpPr/>
           <p:nvPr/>
-        </p:nvPicPr>
-        <p:blipFill>
-          <a:blip r:embed="rId7">
-            <a:extLst>
-              <a:ext uri="{28A0092B-C50C-407E-A947-70E740481C1C}">
-                <a14:useLocalDpi xmlns:a14="http://schemas.microsoft.com/office/drawing/2010/main" val="0"/>
-              </a:ext>
-            </a:extLst>
-          </a:blip>
-          <a:srcRect/>
-          <a:stretch>
-            <a:fillRect/>
-          </a:stretch>
-        </p:blipFill>
-        <p:spPr bwMode="auto">
+        </p:nvSpPr>
+        <p:spPr>
           <a:xfrm>
-            <a:off x="446396" y="4511680"/>
-            <a:ext cx="2857500" cy="2857500"/>
+            <a:off x="825500" y="4127500"/>
+            <a:ext cx="2349500" cy="736600"/>
           </a:xfrm>
-          <a:prstGeom prst="rect">
+          <a:prstGeom prst="roundRect">
             <a:avLst/>
           </a:prstGeom>
-          <a:noFill/>
-          <a:extLst>
-            <a:ext uri="{909E8E84-426E-40DD-AFC4-6F175D3DCCD1}">
-              <a14:hiddenFill xmlns:a14="http://schemas.microsoft.com/office/drawing/2010/main">
+          <a:solidFill>
+            <a:srgbClr val="DEF2FF"/>
+          </a:solidFill>
+          <a:ln w="19050">
+            <a:solidFill>
+              <a:srgbClr val="3B85D5"/>
+            </a:solidFill>
+          </a:ln>
+        </p:spPr>
+        <p:style>
+          <a:lnRef idx="2">
+            <a:schemeClr val="accent1">
+              <a:shade val="15000"/>
+            </a:schemeClr>
+          </a:lnRef>
+          <a:fillRef idx="1">
+            <a:schemeClr val="accent1"/>
+          </a:fillRef>
+          <a:effectRef idx="0">
+            <a:schemeClr val="accent1"/>
+          </a:effectRef>
+          <a:fontRef idx="minor">
+            <a:schemeClr val="lt1"/>
+          </a:fontRef>
+        </p:style>
+        <p:txBody>
+          <a:bodyPr lIns="101600" tIns="76200" rIns="101600" rtlCol="0" anchor="ctr"/>
+          <a:lstStyle/>
+          <a:p>
+            <a:pPr algn="ctr"/>
+            <a:r>
+              <a:rPr lang="es-ES" sz="1200" b="1">
                 <a:solidFill>
-                  <a:srgbClr val="FFFFFF"/>
+                  <a:srgbClr val="202020"/>
                 </a:solidFill>
-              </a14:hiddenFill>
-            </a:ext>
-          </a:extLst>
-        </p:spPr>
-      </p:pic>
-      <p:pic>
-        <p:nvPicPr>
-          <p:cNvPr id="1028" name="Picture 4" descr="Tailwind CSS Logo Rounded 67565433 PNG">
+                <a:latin typeface="Arial" panose="020B0604020202020204" pitchFamily="34" charset="0"/>
+              </a:rPr>
+              <a:t>Validación académica</a:t>
+            </a:r>
+          </a:p>
+          <a:p>
+            <a:pPr algn="ctr"/>
+            <a:r>
+              <a:rPr lang="es-ES" sz="1000">
+                <a:solidFill>
+                  <a:srgbClr val="202020"/>
+                </a:solidFill>
+                <a:latin typeface="Arial" panose="020B0604020202020204" pitchFamily="34" charset="0"/>
+              </a:rPr>
+              <a:t>Next.js local en el PC de defensa</a:t>
+            </a:r>
+            <a:endParaRPr lang="es-CL" sz="1000">
+              <a:solidFill>
+                <a:srgbClr val="202020"/>
+              </a:solidFill>
+              <a:latin typeface="Arial" panose="020B0604020202020204" pitchFamily="34" charset="0"/>
+            </a:endParaRPr>
+          </a:p>
+        </p:txBody>
+      </p:sp>
+      <p:sp>
+        <p:nvSpPr>
+          <p:cNvPr id="10" name="Rectángulo: esquinas redondeadas 9">
             <a:extLst>
               <a:ext uri="{FF2B5EF4-FFF2-40B4-BE49-F238E27FC236}">
-                <a16:creationId xmlns:a16="http://schemas.microsoft.com/office/drawing/2014/main" id="{ADB4F0FD-52E6-02EC-E0D8-4D39C0D31D7F}"/>
+                <a16:creationId xmlns:a16="http://schemas.microsoft.com/office/drawing/2014/main" id="{F0040D24-DFE6-66DD-279F-304C8F91DA26}"/>
               </a:ext>
             </a:extLst>
           </p:cNvPr>
-          <p:cNvPicPr>
-            <a:picLocks noChangeAspect="1" noChangeArrowheads="1"/>
-          </p:cNvPicPr>
+          <p:cNvSpPr/>
           <p:nvPr/>
-        </p:nvPicPr>
-        <p:blipFill>
-          <a:blip r:embed="rId8">
-            <a:extLst>
-              <a:ext uri="{28A0092B-C50C-407E-A947-70E740481C1C}">
-                <a14:useLocalDpi xmlns:a14="http://schemas.microsoft.com/office/drawing/2010/main" val="0"/>
-              </a:ext>
-            </a:extLst>
-          </a:blip>
-          <a:srcRect/>
-          <a:stretch>
-            <a:fillRect/>
-          </a:stretch>
-        </p:blipFill>
-        <p:spPr bwMode="auto">
+        </p:nvSpPr>
+        <p:spPr>
           <a:xfrm>
-            <a:off x="4201424" y="5353417"/>
-            <a:ext cx="1349829" cy="1349829"/>
+            <a:off x="3403600" y="4127500"/>
+            <a:ext cx="2349500" cy="736600"/>
           </a:xfrm>
-          <a:prstGeom prst="rect">
+          <a:prstGeom prst="roundRect">
             <a:avLst/>
           </a:prstGeom>
-          <a:noFill/>
-          <a:extLst>
-            <a:ext uri="{909E8E84-426E-40DD-AFC4-6F175D3DCCD1}">
-              <a14:hiddenFill xmlns:a14="http://schemas.microsoft.com/office/drawing/2010/main">
+          <a:solidFill>
+            <a:srgbClr val="EEF7E5"/>
+          </a:solidFill>
+          <a:ln w="19050">
+            <a:solidFill>
+              <a:srgbClr val="7FA362"/>
+            </a:solidFill>
+          </a:ln>
+        </p:spPr>
+        <p:style>
+          <a:lnRef idx="2">
+            <a:schemeClr val="accent1">
+              <a:shade val="15000"/>
+            </a:schemeClr>
+          </a:lnRef>
+          <a:fillRef idx="1">
+            <a:schemeClr val="accent1"/>
+          </a:fillRef>
+          <a:effectRef idx="0">
+            <a:schemeClr val="accent1"/>
+          </a:effectRef>
+          <a:fontRef idx="minor">
+            <a:schemeClr val="lt1"/>
+          </a:fontRef>
+        </p:style>
+        <p:txBody>
+          <a:bodyPr lIns="101600" tIns="76200" rIns="101600" rtlCol="0" anchor="ctr"/>
+          <a:lstStyle/>
+          <a:p>
+            <a:pPr algn="ctr"/>
+            <a:r>
+              <a:rPr lang="es-CL" sz="1200" b="1">
                 <a:solidFill>
-                  <a:srgbClr val="FFFFFF"/>
+                  <a:srgbClr val="202020"/>
                 </a:solidFill>
-              </a14:hiddenFill>
-            </a:ext>
-          </a:extLst>
-        </p:spPr>
-      </p:pic>
-      <p:pic>
-        <p:nvPicPr>
-          <p:cNvPr id="8" name="Imagen 7">
+                <a:latin typeface="Arial" panose="020B0604020202020204" pitchFamily="34" charset="0"/>
+              </a:rPr>
+              <a:t>Servicios externos</a:t>
+            </a:r>
+          </a:p>
+          <a:p>
+            <a:pPr algn="ctr"/>
+            <a:r>
+              <a:rPr lang="es-CL" sz="1000">
+                <a:solidFill>
+                  <a:srgbClr val="202020"/>
+                </a:solidFill>
+                <a:latin typeface="Arial" panose="020B0604020202020204" pitchFamily="34" charset="0"/>
+              </a:rPr>
+              <a:t>Supabase Cloud: Auth + PostgreSQL</a:t>
+            </a:r>
+          </a:p>
+        </p:txBody>
+      </p:sp>
+      <p:sp>
+        <p:nvSpPr>
+          <p:cNvPr id="12" name="Rectángulo: esquinas redondeadas 11">
             <a:extLst>
               <a:ext uri="{FF2B5EF4-FFF2-40B4-BE49-F238E27FC236}">
-                <a16:creationId xmlns:a16="http://schemas.microsoft.com/office/drawing/2014/main" id="{654799DE-A2F6-8E96-2480-2759ECB543F3}"/>
+                <a16:creationId xmlns:a16="http://schemas.microsoft.com/office/drawing/2014/main" id="{DB63A8AA-E74A-DF6B-F089-1A269E1334A3}"/>
               </a:ext>
             </a:extLst>
           </p:cNvPr>
-          <p:cNvPicPr>
-            <a:picLocks noChangeAspect="1"/>
-          </p:cNvPicPr>
+          <p:cNvSpPr/>
           <p:nvPr/>
-        </p:nvPicPr>
-        <p:blipFill>
-          <a:blip r:embed="rId9"/>
-          <a:stretch>
-            <a:fillRect/>
-          </a:stretch>
-        </p:blipFill>
+        </p:nvSpPr>
         <p:spPr>
           <a:xfrm>
-            <a:off x="1553701" y="4070674"/>
-            <a:ext cx="1283780" cy="1142564"/>
+            <a:off x="5981700" y="4127500"/>
+            <a:ext cx="2349500" cy="736600"/>
           </a:xfrm>
-          <a:prstGeom prst="rect">
+          <a:prstGeom prst="roundRect">
             <a:avLst/>
           </a:prstGeom>
+          <a:solidFill>
+            <a:srgbClr val="FFF2EA"/>
+          </a:solidFill>
+          <a:ln w="19050">
+            <a:solidFill>
+              <a:srgbClr val="C27C47"/>
+            </a:solidFill>
+          </a:ln>
         </p:spPr>
-      </p:pic>
-      <p:pic>
-        <p:nvPicPr>
-          <p:cNvPr id="10" name="Imagen 9">
-            <a:extLst>
-              <a:ext uri="{FF2B5EF4-FFF2-40B4-BE49-F238E27FC236}">
-                <a16:creationId xmlns:a16="http://schemas.microsoft.com/office/drawing/2014/main" id="{95E533F0-75E1-4FA7-6176-9023A66A6490}"/>
-              </a:ext>
-            </a:extLst>
-          </p:cNvPr>
-          <p:cNvPicPr>
-            <a:picLocks noChangeAspect="1"/>
-          </p:cNvPicPr>
-          <p:nvPr/>
-        </p:nvPicPr>
-        <p:blipFill>
-          <a:blip r:embed="rId10"/>
-          <a:stretch>
-            <a:fillRect/>
-          </a:stretch>
-        </p:blipFill>
-        <p:spPr>
-          <a:xfrm>
-            <a:off x="4201424" y="3942662"/>
-            <a:ext cx="1310790" cy="1245484"/>
-          </a:xfrm>
-          <a:prstGeom prst="rect">
-            <a:avLst/>
-          </a:prstGeom>
-        </p:spPr>
-      </p:pic>
-      <p:pic>
-        <p:nvPicPr>
-          <p:cNvPr id="12" name="Imagen 11">
-            <a:extLst>
-              <a:ext uri="{FF2B5EF4-FFF2-40B4-BE49-F238E27FC236}">
-                <a16:creationId xmlns:a16="http://schemas.microsoft.com/office/drawing/2014/main" id="{51B34E96-B0DB-151D-84CF-F87B69A3EA27}"/>
-              </a:ext>
-            </a:extLst>
-          </p:cNvPr>
-          <p:cNvPicPr>
-            <a:picLocks noChangeAspect="1"/>
-          </p:cNvPicPr>
-          <p:nvPr/>
-        </p:nvPicPr>
-        <p:blipFill>
-          <a:blip r:embed="rId11"/>
-          <a:stretch>
-            <a:fillRect/>
-          </a:stretch>
-        </p:blipFill>
-        <p:spPr>
-          <a:xfrm>
-            <a:off x="6825410" y="5553394"/>
-            <a:ext cx="1073130" cy="1073130"/>
-          </a:xfrm>
-          <a:prstGeom prst="rect">
-            <a:avLst/>
-          </a:prstGeom>
-        </p:spPr>
-      </p:pic>
-      <p:pic>
-        <p:nvPicPr>
-          <p:cNvPr id="14" name="Imagen 13">
-            <a:extLst>
-              <a:ext uri="{FF2B5EF4-FFF2-40B4-BE49-F238E27FC236}">
-                <a16:creationId xmlns:a16="http://schemas.microsoft.com/office/drawing/2014/main" id="{D62B4C00-6B7E-F0F3-FA87-45BA05503048}"/>
-              </a:ext>
-            </a:extLst>
-          </p:cNvPr>
-          <p:cNvPicPr>
-            <a:picLocks noChangeAspect="1"/>
-          </p:cNvPicPr>
-          <p:nvPr/>
-        </p:nvPicPr>
-        <p:blipFill>
-          <a:blip r:embed="rId12"/>
-          <a:stretch>
-            <a:fillRect/>
-          </a:stretch>
-        </p:blipFill>
-        <p:spPr>
-          <a:xfrm>
-            <a:off x="6662815" y="3942662"/>
-            <a:ext cx="1398320" cy="1442017"/>
-          </a:xfrm>
-          <a:prstGeom prst="rect">
-            <a:avLst/>
-          </a:prstGeom>
-        </p:spPr>
-      </p:pic>
+        <p:style>
+          <a:lnRef idx="2">
+            <a:schemeClr val="accent1">
+              <a:shade val="15000"/>
+            </a:schemeClr>
+          </a:lnRef>
+          <a:fillRef idx="1">
+            <a:schemeClr val="accent1"/>
+          </a:fillRef>
+          <a:effectRef idx="0">
+            <a:schemeClr val="accent1"/>
+          </a:effectRef>
+          <a:fontRef idx="minor">
+            <a:schemeClr val="lt1"/>
+          </a:fontRef>
+        </p:style>
+        <p:txBody>
+          <a:bodyPr lIns="101600" tIns="76200" rIns="101600" rtlCol="0" anchor="ctr"/>
+          <a:lstStyle/>
+          <a:p>
+            <a:pPr algn="ctr"/>
+            <a:r>
+              <a:rPr lang="es-ES" sz="1200" b="1">
+                <a:solidFill>
+                  <a:srgbClr val="202020"/>
+                </a:solidFill>
+                <a:latin typeface="Arial" panose="020B0604020202020204" pitchFamily="34" charset="0"/>
+              </a:rPr>
+              <a:t>Evolución futura</a:t>
+            </a:r>
+          </a:p>
+          <a:p>
+            <a:pPr algn="ctr"/>
+            <a:r>
+              <a:rPr lang="es-ES" sz="1000">
+                <a:solidFill>
+                  <a:srgbClr val="202020"/>
+                </a:solidFill>
+                <a:latin typeface="Arial" panose="020B0604020202020204" pitchFamily="34" charset="0"/>
+              </a:rPr>
+              <a:t>Vercel u otra plataforma compatible</a:t>
+            </a:r>
+            <a:endParaRPr lang="es-CL" sz="1000">
+              <a:solidFill>
+                <a:srgbClr val="202020"/>
+              </a:solidFill>
+              <a:latin typeface="Arial" panose="020B0604020202020204" pitchFamily="34" charset="0"/>
+            </a:endParaRPr>
+          </a:p>
+        </p:txBody>
+      </p:sp>
     </p:spTree>
     <p:extLst>
       <p:ext uri="{BB962C8B-B14F-4D97-AF65-F5344CB8AC3E}">

</xml_diff>